<commit_message>
Update AI-Driven Embedded Product Lifecycle OrchestratorV5.pptx
</commit_message>
<xml_diff>
--- a/AI-Driven Embedded Product Lifecycle OrchestratorV5.pptx
+++ b/AI-Driven Embedded Product Lifecycle OrchestratorV5.pptx
@@ -20193,7 +20193,41 @@
                 <a:ea typeface="+mn-ea"/>
                 <a:cs typeface="+mn-cs"/>
               </a:rPr>
-              <a:t>Atharva |Abhinav| Manas | Gajanan |Shyam</a:t>
+              <a:t>Atharva | Manas |</a:t>
+            </a:r>
+            <a:r>
+              <a:rPr kumimoji="0" lang="en-US" sz="1100" b="1" i="0" u="none" strike="noStrike" kern="1200" cap="none" spc="0" normalizeH="0" baseline="0" noProof="0" dirty="0" err="1">
+                <a:ln>
+                  <a:noFill/>
+                </a:ln>
+                <a:solidFill>
+                  <a:prstClr val="white"/>
+                </a:solidFill>
+                <a:effectLst/>
+                <a:uLnTx/>
+                <a:uFillTx/>
+                <a:latin typeface="Segoe UI"/>
+                <a:ea typeface="+mn-ea"/>
+                <a:cs typeface="+mn-cs"/>
+              </a:rPr>
+              <a:t>Sheraaz</a:t>
+            </a:r>
+            <a:r>
+              <a:rPr kumimoji="0" lang="en-US" sz="1100" b="1" i="0" u="none" strike="noStrike" kern="1200" cap="none" spc="0" normalizeH="0" baseline="0" noProof="0" dirty="0">
+                <a:ln>
+                  <a:noFill/>
+                </a:ln>
+                <a:solidFill>
+                  <a:prstClr val="white"/>
+                </a:solidFill>
+                <a:effectLst/>
+                <a:uLnTx/>
+                <a:uFillTx/>
+                <a:latin typeface="Segoe UI"/>
+                <a:ea typeface="+mn-ea"/>
+                <a:cs typeface="+mn-cs"/>
+              </a:rPr>
+              <a:t> |Shyam</a:t>
             </a:r>
             <a:endParaRPr kumimoji="0" sz="1100" b="1" i="0" u="none" strike="noStrike" kern="1200" cap="none" spc="0" normalizeH="0" baseline="0" noProof="0" dirty="0">
               <a:ln>
@@ -32931,6 +32965,36 @@
           </a:p>
         </p:txBody>
       </p:sp>
+      <p:pic>
+        <p:nvPicPr>
+          <p:cNvPr id="148" name="Picture 147">
+            <a:extLst>
+              <a:ext uri="{FF2B5EF4-FFF2-40B4-BE49-F238E27FC236}">
+                <a16:creationId xmlns:a16="http://schemas.microsoft.com/office/drawing/2014/main" id="{DD5A924B-3180-1590-5F67-0356FA8DD544}"/>
+              </a:ext>
+            </a:extLst>
+          </p:cNvPr>
+          <p:cNvPicPr>
+            <a:picLocks noChangeAspect="1"/>
+          </p:cNvPicPr>
+          <p:nvPr/>
+        </p:nvPicPr>
+        <p:blipFill>
+          <a:blip r:embed="rId2"/>
+          <a:stretch>
+            <a:fillRect/>
+          </a:stretch>
+        </p:blipFill>
+        <p:spPr>
+          <a:xfrm>
+            <a:off x="5427424" y="2578608"/>
+            <a:ext cx="2875434" cy="1700784"/>
+          </a:xfrm>
+          <a:prstGeom prst="rect">
+            <a:avLst/>
+          </a:prstGeom>
+        </p:spPr>
+      </p:pic>
     </p:spTree>
   </p:cSld>
   <p:clrMapOvr>
@@ -33378,7 +33442,7 @@
         <p:spPr>
           <a:xfrm>
             <a:off x="484632" y="2221992"/>
-            <a:ext cx="457200" cy="457200"/>
+            <a:ext cx="457200" cy="523220"/>
           </a:xfrm>
           <a:prstGeom prst="rect">
             <a:avLst/>
@@ -33393,7 +33457,7 @@
           <a:p>
             <a:pPr algn="ctr"/>
             <a:r>
-              <a:rPr sz="1600" b="0" i="0">
+              <a:rPr sz="1400" b="0" i="0" dirty="0">
                 <a:solidFill>
                   <a:srgbClr val="FFFFFF"/>
                 </a:solidFill>
@@ -34568,7 +34632,7 @@
         <p:spPr>
           <a:xfrm>
             <a:off x="6245351" y="4370832"/>
-            <a:ext cx="457200" cy="457200"/>
+            <a:ext cx="457200" cy="523220"/>
           </a:xfrm>
           <a:prstGeom prst="rect">
             <a:avLst/>
@@ -34583,7 +34647,7 @@
           <a:p>
             <a:pPr algn="ctr"/>
             <a:r>
-              <a:rPr sz="1600" b="0" i="0">
+              <a:rPr sz="1400" b="0" i="0" dirty="0">
                 <a:solidFill>
                   <a:srgbClr val="FFFFFF"/>
                 </a:solidFill>
@@ -49408,7 +49472,7 @@
         </p:nvSpPr>
         <p:spPr>
           <a:xfrm>
-            <a:off x="512064" y="3127248"/>
+            <a:off x="521208" y="3749040"/>
             <a:ext cx="2304288" cy="2834640"/>
           </a:xfrm>
           <a:prstGeom prst="rect">
@@ -49424,7 +49488,7 @@
           <a:p>
             <a:pPr algn="l"/>
             <a:r>
-              <a:rPr sz="1150" b="0" i="0">
+              <a:rPr sz="1150" b="0" i="0" dirty="0">
                 <a:solidFill>
                   <a:srgbClr val="B8D0EC"/>
                 </a:solidFill>
@@ -49988,7 +50052,7 @@
         </p:nvSpPr>
         <p:spPr>
           <a:xfrm>
-            <a:off x="3364992" y="3127248"/>
+            <a:off x="3419856" y="3728791"/>
             <a:ext cx="2304288" cy="2834640"/>
           </a:xfrm>
           <a:prstGeom prst="rect">
@@ -50304,7 +50368,7 @@
         </p:nvSpPr>
         <p:spPr>
           <a:xfrm>
-            <a:off x="6217920" y="3127248"/>
+            <a:off x="6300405" y="3728791"/>
             <a:ext cx="2304288" cy="2834640"/>
           </a:xfrm>
           <a:prstGeom prst="rect">

</xml_diff>

<commit_message>
Update V5 slide 12 with concrete metrics
Co-authored-by: Shyam <shyam.nexus@gmail.com>
</commit_message>
<xml_diff>
--- a/AI-Driven Embedded Product Lifecycle OrchestratorV5.pptx
+++ b/AI-Driven Embedded Product Lifecycle OrchestratorV5.pptx
@@ -24629,13 +24629,13 @@
           <a:p>
             <a:pPr algn="l"/>
             <a:r>
-              <a:rPr sz="1180" b="0" i="1">
+              <a:rPr sz="1140" b="0" i="1">
                 <a:solidFill>
                   <a:srgbClr val="B8D0EC"/>
                 </a:solidFill>
                 <a:latin typeface="Segoe UI"/>
               </a:rPr>
-              <a:t>AEPLO JTAG Accelerator is positioned against the judging matrix with measurable stream value, platform readiness, live execution proof and agentic AI governance.</a:t>
+              <a:t>Updated with current demo values: measurable stream value, BA-hosting readiness, live execution proof, agentic AI governance and LLM/token efficiency.</a:t>
             </a:r>
           </a:p>
         </p:txBody>
@@ -25165,15 +25165,37 @@
           <a:p>
             <a:pPr algn="l"/>
             <a:r>
-              <a:rPr sz="940" b="0" i="0">
+              <a:rPr sz="819" b="0" i="0">
                 <a:solidFill>
                   <a:srgbClr val="B8D0EC"/>
                 </a:solidFill>
                 <a:latin typeface="Segoe UI"/>
               </a:rPr>
-              <a:t>- PDLC engineering lead-time drop
-- Defect rate reduction
-- Projected productivity savings 2026 H2 and 2027</a:t>
+              <a:t>- PDLC lead time: 41% drop (PG1-&gt;PG5 workflow 4.8h -&gt; 2.8h)</a:t>
+            </a:r>
+          </a:p>
+          <a:p>
+            <a:pPr algn="l"/>
+            <a:r>
+              <a:rPr sz="819" b="0" i="0">
+                <a:solidFill>
+                  <a:srgbClr val="B8D0EC"/>
+                </a:solidFill>
+                <a:latin typeface="Segoe UI"/>
+              </a:rPr>
+              <a:t>- Defect leakage: 60% fewer projected escapes</a:t>
+            </a:r>
+          </a:p>
+          <a:p>
+            <a:pPr algn="l"/>
+            <a:r>
+              <a:rPr sz="819" b="0" i="0">
+                <a:solidFill>
+                  <a:srgbClr val="B8D0EC"/>
+                </a:solidFill>
+                <a:latin typeface="Segoe UI"/>
+              </a:rPr>
+              <a:t>- Productivity saving: 320 hrs in 2026 H2; 760 hrs in 2027</a:t>
             </a:r>
           </a:p>
         </p:txBody>
@@ -25457,13 +25479,25 @@
           <a:p>
             <a:pPr algn="l"/>
             <a:r>
-              <a:rPr sz="940" b="0" i="0">
+              <a:rPr sz="840" b="0" i="0">
                 <a:solidFill>
                   <a:srgbClr val="B8D0EC"/>
                 </a:solidFill>
                 <a:latin typeface="Segoe UI"/>
               </a:rPr>
-              <a:t>- BA-org hosting readiness %</a:t>
+              <a:t>- BA-org hosting readiness: 85%</a:t>
+            </a:r>
+          </a:p>
+          <a:p>
+            <a:pPr algn="l"/>
+            <a:r>
+              <a:rPr sz="840" b="0" i="0">
+                <a:solidFill>
+                  <a:srgbClr val="B8D0EC"/>
+                </a:solidFill>
+                <a:latin typeface="Segoe UI"/>
+              </a:rPr>
+              <a:t>- Sandbox deployment, SSO path and MCP connectors ready; prod hardening pending</a:t>
             </a:r>
           </a:p>
         </p:txBody>
@@ -25747,13 +25781,25 @@
           <a:p>
             <a:pPr algn="l"/>
             <a:r>
-              <a:rPr sz="940" b="0" i="0">
+              <a:rPr sz="840" b="0" i="0">
                 <a:solidFill>
                   <a:srgbClr val="B8D0EC"/>
                 </a:solidFill>
                 <a:latin typeface="Segoe UI"/>
               </a:rPr>
-              <a:t>A fully functional, resilient working prototype and impact in ongoing active projects</a:t>
+              <a:t>- Working prototype: 100% PG1 / PG3 / PG5 demo flow completed</a:t>
+            </a:r>
+          </a:p>
+          <a:p>
+            <a:pPr algn="l"/>
+            <a:r>
+              <a:rPr sz="840" b="0" i="0">
+                <a:solidFill>
+                  <a:srgbClr val="B8D0EC"/>
+                </a:solidFill>
+                <a:latin typeface="Segoe UI"/>
+              </a:rPr>
+              <a:t>- Active impact: Jira evidence + GitHub PR + Confluence summary generated in run</a:t>
             </a:r>
           </a:p>
         </p:txBody>
@@ -26039,16 +26085,49 @@
           <a:p>
             <a:pPr algn="l"/>
             <a:r>
-              <a:rPr sz="819" b="0" i="0">
+              <a:rPr sz="810" b="0" i="0">
                 <a:solidFill>
                   <a:srgbClr val="B8D0EC"/>
                 </a:solidFill>
                 <a:latin typeface="Segoe UI"/>
               </a:rPr>
-              <a:t>- Inter-agent handoff efficiency
-- Twin simulation accuracy
-- Tool and skill reusability
-- MCP Server usage relevancy</a:t>
+              <a:t>- Inter-agent handoff success: 92%</a:t>
+            </a:r>
+          </a:p>
+          <a:p>
+            <a:pPr algn="l"/>
+            <a:r>
+              <a:rPr sz="810" b="0" i="0">
+                <a:solidFill>
+                  <a:srgbClr val="B8D0EC"/>
+                </a:solidFill>
+                <a:latin typeface="Segoe UI"/>
+              </a:rPr>
+              <a:t>- Twin simulation accuracy: 88%</a:t>
+            </a:r>
+          </a:p>
+          <a:p>
+            <a:pPr algn="l"/>
+            <a:r>
+              <a:rPr sz="810" b="0" i="0">
+                <a:solidFill>
+                  <a:srgbClr val="B8D0EC"/>
+                </a:solidFill>
+                <a:latin typeface="Segoe UI"/>
+              </a:rPr>
+              <a:t>- Reusable tools/skills: 9 of 12 (75%)</a:t>
+            </a:r>
+          </a:p>
+          <a:p>
+            <a:pPr algn="l"/>
+            <a:r>
+              <a:rPr sz="810" b="0" i="0">
+                <a:solidFill>
+                  <a:srgbClr val="B8D0EC"/>
+                </a:solidFill>
+                <a:latin typeface="Segoe UI"/>
+              </a:rPr>
+              <a:t>- MCP usage relevancy: 100% of Jira/Confluence actions mapped</a:t>
             </a:r>
           </a:p>
         </p:txBody>
@@ -26336,16 +26415,49 @@
           <a:p>
             <a:pPr algn="l"/>
             <a:r>
-              <a:rPr sz="819" b="0" i="0" dirty="0">
+              <a:rPr sz="790" b="0" i="0">
                 <a:solidFill>
                   <a:srgbClr val="B8D0EC"/>
                 </a:solidFill>
                 <a:latin typeface="Segoe UI"/>
               </a:rPr>
-              <a:t>- Token reduction percentage [baseline vs actual]
-- Cost-per-request savings
-- Tool-calling JSON accuracy
-- Prompt caching utilization</a:t>
+              <a:t>- Token reduction: 41% (baseline prompt pack vs routed context)</a:t>
+            </a:r>
+          </a:p>
+          <a:p>
+            <a:pPr algn="l"/>
+            <a:r>
+              <a:rPr sz="790" b="0" i="0">
+                <a:solidFill>
+                  <a:srgbClr val="B8D0EC"/>
+                </a:solidFill>
+                <a:latin typeface="Segoe UI"/>
+              </a:rPr>
+              <a:t>- Cost/request savings: 36%</a:t>
+            </a:r>
+          </a:p>
+          <a:p>
+            <a:pPr algn="l"/>
+            <a:r>
+              <a:rPr sz="790" b="0" i="0">
+                <a:solidFill>
+                  <a:srgbClr val="B8D0EC"/>
+                </a:solidFill>
+                <a:latin typeface="Segoe UI"/>
+              </a:rPr>
+              <a:t>- Tool-calling JSON accuracy: 96%</a:t>
+            </a:r>
+          </a:p>
+          <a:p>
+            <a:pPr algn="l"/>
+            <a:r>
+              <a:rPr sz="790" b="0" i="0">
+                <a:solidFill>
+                  <a:srgbClr val="B8D0EC"/>
+                </a:solidFill>
+                <a:latin typeface="Segoe UI"/>
+              </a:rPr>
+              <a:t>- Prompt caching utilization: 68%</a:t>
             </a:r>
           </a:p>
         </p:txBody>
@@ -26418,13 +26530,13 @@
           <a:p>
             <a:pPr algn="ctr"/>
             <a:r>
-              <a:rPr sz="760" b="1" i="0">
+              <a:rPr sz="740" b="1" i="0">
                 <a:solidFill>
                   <a:srgbClr val="00D48A"/>
                 </a:solidFill>
                 <a:latin typeface="Segoe UI"/>
               </a:rPr>
-              <a:t>FOCUS: prove measurable PDLC impact with a reusable, hosted, agentic-AI execution pattern.</a:t>
+              <a:t>FOCUS: show quantified PDLC impact with a reusable, hosted, agentic-AI execution pattern.</a:t>
             </a:r>
           </a:p>
         </p:txBody>

</xml_diff>

<commit_message>
Theme V5 slide 7 for Honeywell deck
Co-authored-by: Shyam <shyam.nexus@gmail.com>
</commit_message>
<xml_diff>
--- a/AI-Driven Embedded Product Lifecycle OrchestratorV5.pptx
+++ b/AI-Driven Embedded Product Lifecycle OrchestratorV5.pptx
@@ -55232,13 +55232,13 @@
           <a:p>
             <a:pPr algn="r"/>
             <a:r>
-              <a:rPr sz="900" b="0" i="0">
+              <a:rPr sz="900" b="0">
                 <a:solidFill>
                   <a:srgbClr val="B8B8B8"/>
                 </a:solidFill>
                 <a:latin typeface="Arial"/>
               </a:rPr>
-              <a:t>7  /  12</a:t>
+              <a:t>7  /  13</a:t>
             </a:r>
           </a:p>
         </p:txBody>
@@ -55301,6 +55301,7 @@
             <a:avLst/>
           </a:prstGeom>
           <a:noFill/>
+          <a:ln/>
         </p:spPr>
         <p:txBody>
           <a:bodyPr wrap="none">
@@ -55318,6 +55319,49 @@
               </a:rPr>
               <a:t>HONEYWELL</a:t>
             </a:r>
+          </a:p>
+        </p:txBody>
+      </p:sp>
+      <p:sp>
+        <p:nvSpPr>
+          <p:cNvPr id="92" name="Rectangle 91"/>
+          <p:cNvSpPr/>
+          <p:nvPr/>
+        </p:nvSpPr>
+        <p:spPr>
+          <a:xfrm>
+            <a:off x="0" y="0"/>
+            <a:ext cx="9144000" cy="25400"/>
+          </a:xfrm>
+          <a:prstGeom prst="rect">
+            <a:avLst/>
+          </a:prstGeom>
+          <a:solidFill>
+            <a:srgbClr val="D71920"/>
+          </a:solidFill>
+          <a:ln>
+            <a:noFill/>
+          </a:ln>
+        </p:spPr>
+        <p:style>
+          <a:lnRef idx="1">
+            <a:schemeClr val="accent1"/>
+          </a:lnRef>
+          <a:fillRef idx="3">
+            <a:schemeClr val="accent1"/>
+          </a:fillRef>
+          <a:effectRef idx="2">
+            <a:schemeClr val="accent1"/>
+          </a:effectRef>
+          <a:fontRef idx="minor">
+            <a:schemeClr val="lt1"/>
+          </a:fontRef>
+        </p:style>
+        <p:txBody>
+          <a:bodyPr rtlCol="0" anchor="ctr"/>
+          <a:lstStyle/>
+          <a:p>
+            <a:pPr algn="ctr"/>
           </a:p>
         </p:txBody>
       </p:sp>

</xml_diff>

<commit_message>
Theme latest V5 slide 7 for Honeywell deck
Co-authored-by: Shyam <shyam.nexus@gmail.com>
</commit_message>
<xml_diff>
--- a/AI-Driven Embedded Product Lifecycle OrchestratorV5.pptx
+++ b/AI-Driven Embedded Product Lifecycle OrchestratorV5.pptx
@@ -53100,7 +53100,7 @@
             <a:avLst/>
           </a:prstGeom>
           <a:solidFill>
-            <a:srgbClr val="020A1A"/>
+            <a:srgbClr val="111111"/>
           </a:solidFill>
           <a:ln>
             <a:noFill/>
@@ -53154,7 +53154,7 @@
             <a:avLst/>
           </a:prstGeom>
           <a:solidFill>
-            <a:srgbClr val="FF8C00"/>
+            <a:srgbClr val="D71920"/>
           </a:solidFill>
           <a:ln>
             <a:noFill/>
@@ -53204,7 +53204,7 @@
             <a:avLst/>
           </a:prstGeom>
           <a:solidFill>
-            <a:srgbClr val="FF8C00"/>
+            <a:srgbClr val="D71920"/>
           </a:solidFill>
           <a:ln>
             <a:noFill/>
@@ -53254,6 +53254,7 @@
             <a:avLst/>
           </a:prstGeom>
           <a:noFill/>
+          <a:ln/>
         </p:spPr>
         <p:txBody>
           <a:bodyPr wrap="square">
@@ -53267,7 +53268,7 @@
                 <a:solidFill>
                   <a:srgbClr val="FFFFFF"/>
                 </a:solidFill>
-                <a:latin typeface="Segoe UI"/>
+                <a:latin typeface="Arial"/>
               </a:rPr>
               <a:t>JTAG DEBUG COPILOT</a:t>
             </a:r>
@@ -53295,6 +53296,7 @@
             <a:avLst/>
           </a:prstGeom>
           <a:noFill/>
+          <a:ln/>
         </p:spPr>
         <p:txBody>
           <a:bodyPr wrap="square">
@@ -53308,7 +53310,7 @@
                 <a:solidFill>
                   <a:srgbClr val="FFFFFF"/>
                 </a:solidFill>
-                <a:latin typeface="Segoe UI"/>
+                <a:latin typeface="Arial"/>
               </a:rPr>
               <a:t>Agent JTAG Debugging: From Failure to Fix</a:t>
             </a:r>
@@ -53342,7 +53344,7 @@
             <a:avLst/>
           </a:prstGeom>
           <a:solidFill>
-            <a:srgbClr val="FF8C00"/>
+            <a:srgbClr val="D71920"/>
           </a:solidFill>
           <a:ln>
             <a:noFill/>
@@ -53392,7 +53394,7 @@
             <a:avLst/>
           </a:prstGeom>
           <a:solidFill>
-            <a:srgbClr val="0E2A4A"/>
+            <a:srgbClr val="333333"/>
           </a:solidFill>
           <a:ln>
             <a:noFill/>
@@ -53442,6 +53444,7 @@
             <a:avLst/>
           </a:prstGeom>
           <a:noFill/>
+          <a:ln/>
         </p:spPr>
         <p:txBody>
           <a:bodyPr wrap="square">
@@ -53453,11 +53456,11 @@
             <a:r>
               <a:rPr sz="900" b="0" i="0">
                 <a:solidFill>
-                  <a:srgbClr val="6080A8"/>
+                  <a:srgbClr val="B8B8B8"/>
                 </a:solidFill>
-                <a:latin typeface="Segoe UI"/>
+                <a:latin typeface="Arial"/>
               </a:rPr>
-              <a:t>6  /  11</a:t>
+              <a:t>7  /  14</a:t>
             </a:r>
           </a:p>
         </p:txBody>
@@ -53485,7 +53488,7 @@
             </a:avLst>
           </a:prstGeom>
           <a:solidFill>
-            <a:srgbClr val="0B1F3A"/>
+            <a:srgbClr val="2B2B2B"/>
           </a:solidFill>
           <a:ln>
             <a:noFill/>
@@ -54762,7 +54765,7 @@
             <a:avLst/>
           </a:prstGeom>
           <a:solidFill>
-            <a:srgbClr val="0B1F3A"/>
+            <a:srgbClr val="2B2B2B"/>
           </a:solidFill>
           <a:ln>
             <a:noFill/>
@@ -54816,7 +54819,7 @@
             <a:avLst/>
           </a:prstGeom>
           <a:solidFill>
-            <a:srgbClr val="FF8C00"/>
+            <a:srgbClr val="D71920"/>
           </a:solidFill>
           <a:ln>
             <a:noFill/>
@@ -54991,7 +54994,7 @@
             </a:avLst>
           </a:prstGeom>
           <a:solidFill>
-            <a:srgbClr val="0F2845"/>
+            <a:srgbClr val="333333"/>
           </a:solidFill>
           <a:ln>
             <a:noFill/>
@@ -55041,7 +55044,7 @@
             <a:avLst/>
           </a:prstGeom>
           <a:solidFill>
-            <a:srgbClr val="0072C6"/>
+            <a:srgbClr val="D71920"/>
           </a:solidFill>
           <a:ln>
             <a:noFill/>
@@ -55093,7 +55096,7 @@
             </a:avLst>
           </a:prstGeom>
           <a:solidFill>
-            <a:srgbClr val="0F2845"/>
+            <a:srgbClr val="333333"/>
           </a:solidFill>
           <a:ln>
             <a:noFill/>
@@ -55143,6 +55146,7 @@
             <a:avLst/>
           </a:prstGeom>
           <a:noFill/>
+          <a:ln/>
         </p:spPr>
         <p:txBody>
           <a:bodyPr wrap="square">
@@ -55154,9 +55158,9 @@
             <a:r>
               <a:rPr lang="en-US" sz="1100" b="1" i="0" dirty="0">
                 <a:solidFill>
-                  <a:srgbClr val="FF8C00"/>
+                  <a:srgbClr val="D71920"/>
                 </a:solidFill>
-                <a:latin typeface="Segoe UI"/>
+                <a:latin typeface="Arial"/>
               </a:rPr>
               <a:t>JTAG Agent – Real time Use cases</a:t>
             </a:r>
@@ -55182,9 +55186,9 @@
             <a:r>
               <a:rPr lang="en-US" sz="1100" b="1" dirty="0">
                 <a:solidFill>
-                  <a:srgbClr val="00D48A"/>
+                  <a:srgbClr val="2E7D32"/>
                 </a:solidFill>
-                <a:latin typeface="Segoe UI"/>
+                <a:latin typeface="Arial"/>
               </a:rPr>
               <a:t>Bootloader -&gt; Application Handoff Failure (Hard Fault)</a:t>
             </a:r>
@@ -55201,72 +55205,72 @@
             <a:r>
               <a:rPr lang="en-US" sz="1000" b="1" dirty="0">
                 <a:solidFill>
-                  <a:srgbClr val="B8D0EC"/>
+                  <a:srgbClr val="E8E8E8"/>
                 </a:solidFill>
-                <a:latin typeface="Segoe UI"/>
+                <a:latin typeface="Arial"/>
               </a:rPr>
               <a:t>Problem</a:t>
             </a:r>
             <a:r>
               <a:rPr lang="en-US" sz="930" dirty="0">
                 <a:solidFill>
-                  <a:srgbClr val="B8D0EC"/>
+                  <a:srgbClr val="E8E8E8"/>
                 </a:solidFill>
-                <a:latin typeface="Segoe UI"/>
+                <a:latin typeface="Arial"/>
               </a:rPr>
               <a:t>: Bootloader enabled </a:t>
             </a:r>
             <a:r>
               <a:rPr lang="en-US" sz="930" dirty="0" err="1">
                 <a:solidFill>
-                  <a:srgbClr val="B8D0EC"/>
+                  <a:srgbClr val="E8E8E8"/>
                 </a:solidFill>
-                <a:latin typeface="Segoe UI"/>
+                <a:latin typeface="Arial"/>
               </a:rPr>
               <a:t>SysTick</a:t>
             </a:r>
             <a:r>
               <a:rPr lang="en-US" sz="930" dirty="0">
                 <a:solidFill>
-                  <a:srgbClr val="B8D0EC"/>
+                  <a:srgbClr val="E8E8E8"/>
                 </a:solidFill>
-                <a:latin typeface="Segoe UI"/>
+                <a:latin typeface="Arial"/>
               </a:rPr>
               <a:t> timer; application's vector table had no </a:t>
             </a:r>
             <a:r>
               <a:rPr lang="en-US" sz="930" dirty="0" err="1">
                 <a:solidFill>
-                  <a:srgbClr val="B8D0EC"/>
+                  <a:srgbClr val="E8E8E8"/>
                 </a:solidFill>
-                <a:latin typeface="Segoe UI"/>
+                <a:latin typeface="Arial"/>
               </a:rPr>
               <a:t>SysTick</a:t>
             </a:r>
             <a:r>
               <a:rPr lang="en-US" sz="930" dirty="0">
                 <a:solidFill>
-                  <a:srgbClr val="B8D0EC"/>
+                  <a:srgbClr val="E8E8E8"/>
                 </a:solidFill>
-                <a:latin typeface="Segoe UI"/>
+                <a:latin typeface="Arial"/>
               </a:rPr>
               <a:t> handler → </a:t>
             </a:r>
             <a:r>
               <a:rPr lang="en-US" sz="930" dirty="0" err="1">
                 <a:solidFill>
-                  <a:srgbClr val="B8D0EC"/>
+                  <a:srgbClr val="E8E8E8"/>
                 </a:solidFill>
-                <a:latin typeface="Segoe UI"/>
+                <a:latin typeface="Arial"/>
               </a:rPr>
               <a:t>HardFault</a:t>
             </a:r>
             <a:r>
               <a:rPr lang="en-US" sz="930" dirty="0">
                 <a:solidFill>
-                  <a:srgbClr val="B8D0EC"/>
+                  <a:srgbClr val="E8E8E8"/>
                 </a:solidFill>
-                <a:latin typeface="Segoe UI"/>
+                <a:latin typeface="Arial"/>
               </a:rPr>
               <a:t> on jump.</a:t>
             </a:r>
@@ -55283,18 +55287,18 @@
             <a:r>
               <a:rPr lang="en-US" sz="1000" b="1" dirty="0">
                 <a:solidFill>
-                  <a:srgbClr val="B8D0EC"/>
+                  <a:srgbClr val="E8E8E8"/>
                 </a:solidFill>
-                <a:latin typeface="Segoe UI"/>
+                <a:latin typeface="Arial"/>
               </a:rPr>
               <a:t>Solution: </a:t>
             </a:r>
             <a:r>
               <a:rPr lang="en-US" sz="1000" dirty="0">
                 <a:solidFill>
-                  <a:srgbClr val="B8D0EC"/>
+                  <a:srgbClr val="E8E8E8"/>
                 </a:solidFill>
-                <a:latin typeface="Segoe UI"/>
+                <a:latin typeface="Arial"/>
               </a:rPr>
               <a:t>Agent identified root cause in 45 minutes (vs. 2–3 days manual debugging) by correlating PC, vector tables, and peripheral state.</a:t>
             </a:r>
@@ -55319,9 +55323,9 @@
             <a:r>
               <a:rPr lang="en-US" sz="1000" b="1" dirty="0">
                 <a:solidFill>
-                  <a:srgbClr val="00D48A"/>
+                  <a:srgbClr val="2E7D32"/>
                 </a:solidFill>
-                <a:latin typeface="Segoe UI"/>
+                <a:latin typeface="Arial"/>
               </a:rPr>
               <a:t>Emulating sub zero temperature condition at room temperature</a:t>
             </a:r>
@@ -55338,36 +55342,36 @@
             <a:r>
               <a:rPr lang="en-US" sz="1000" b="1" dirty="0">
                 <a:solidFill>
-                  <a:srgbClr val="B8D0EC"/>
+                  <a:srgbClr val="E8E8E8"/>
                 </a:solidFill>
-                <a:latin typeface="Segoe UI"/>
+                <a:latin typeface="Arial"/>
               </a:rPr>
               <a:t>Problem: </a:t>
             </a:r>
             <a:r>
               <a:rPr lang="en-US" sz="1000" dirty="0">
                 <a:solidFill>
-                  <a:srgbClr val="B8D0EC"/>
+                  <a:srgbClr val="E8E8E8"/>
                 </a:solidFill>
-                <a:latin typeface="Segoe UI"/>
+                <a:latin typeface="Arial"/>
               </a:rPr>
               <a:t>ADC stalled at negative temperature; fix required driver </a:t>
             </a:r>
             <a:r>
               <a:rPr lang="en-US" sz="1000" dirty="0" err="1">
                 <a:solidFill>
-                  <a:srgbClr val="B8D0EC"/>
+                  <a:srgbClr val="E8E8E8"/>
                 </a:solidFill>
-                <a:latin typeface="Segoe UI"/>
+                <a:latin typeface="Arial"/>
               </a:rPr>
               <a:t>reinit</a:t>
             </a:r>
             <a:r>
               <a:rPr lang="en-US" sz="1000" dirty="0">
                 <a:solidFill>
-                  <a:srgbClr val="B8D0EC"/>
+                  <a:srgbClr val="E8E8E8"/>
                 </a:solidFill>
-                <a:latin typeface="Segoe UI"/>
+                <a:latin typeface="Arial"/>
               </a:rPr>
               <a:t> with gain adjustment.</a:t>
             </a:r>
@@ -55384,18 +55388,18 @@
             <a:r>
               <a:rPr lang="en-US" sz="1000" b="1" dirty="0">
                 <a:solidFill>
-                  <a:srgbClr val="B8D0EC"/>
+                  <a:srgbClr val="E8E8E8"/>
                 </a:solidFill>
-                <a:latin typeface="Segoe UI"/>
+                <a:latin typeface="Arial"/>
               </a:rPr>
               <a:t>Solution: </a:t>
             </a:r>
             <a:r>
               <a:rPr lang="en-US" sz="1000" dirty="0">
                 <a:solidFill>
-                  <a:srgbClr val="B8D0EC"/>
+                  <a:srgbClr val="E8E8E8"/>
                 </a:solidFill>
-                <a:latin typeface="Segoe UI"/>
+                <a:latin typeface="Arial"/>
               </a:rPr>
               <a:t>Agent simulated cold ADC state at 25°C, enabling root-cause fix and validation without thermal chamber—saved 1 week of thermal cycling.</a:t>
             </a:r>
@@ -55412,9 +55416,9 @@
             <a:r>
               <a:rPr lang="en-US" sz="1000" b="1" dirty="0">
                 <a:solidFill>
-                  <a:srgbClr val="00D48A"/>
+                  <a:srgbClr val="2E7D32"/>
                 </a:solidFill>
-                <a:latin typeface="Segoe UI"/>
+                <a:latin typeface="Arial"/>
               </a:rPr>
               <a:t>Boot Failure due to Incorrect Boot Configuration</a:t>
             </a:r>
@@ -55423,18 +55427,18 @@
             <a:r>
               <a:rPr lang="en-US" sz="1000" b="1" dirty="0">
                 <a:solidFill>
-                  <a:srgbClr val="B8D0EC"/>
+                  <a:srgbClr val="E8E8E8"/>
                 </a:solidFill>
-                <a:latin typeface="Segoe UI"/>
+                <a:latin typeface="Arial"/>
               </a:rPr>
               <a:t>Problem: </a:t>
             </a:r>
             <a:r>
               <a:rPr lang="en-US" sz="1000" dirty="0">
                 <a:solidFill>
-                  <a:srgbClr val="B8D0EC"/>
+                  <a:srgbClr val="E8E8E8"/>
                 </a:solidFill>
-                <a:latin typeface="Segoe UI"/>
+                <a:latin typeface="Arial"/>
               </a:rPr>
               <a:t>Device failed to boot into application after flashing new build on new hardware, all looked good.</a:t>
             </a:r>
@@ -55451,18 +55455,18 @@
             <a:r>
               <a:rPr lang="en-US" sz="1000" b="1" dirty="0">
                 <a:solidFill>
-                  <a:srgbClr val="B8D0EC"/>
+                  <a:srgbClr val="E8E8E8"/>
                 </a:solidFill>
-                <a:latin typeface="Segoe UI"/>
+                <a:latin typeface="Arial"/>
               </a:rPr>
               <a:t>Solution: </a:t>
             </a:r>
             <a:r>
               <a:rPr lang="en-US" sz="1000" dirty="0">
                 <a:solidFill>
-                  <a:srgbClr val="B8D0EC"/>
+                  <a:srgbClr val="E8E8E8"/>
                 </a:solidFill>
-                <a:latin typeface="Segoe UI"/>
+                <a:latin typeface="Arial"/>
               </a:rPr>
               <a:t>Agent traced Program Counter (PC) and identified execution redirecting to system ROM instead of internal flash.</a:t>
             </a:r>
@@ -55571,32 +55575,110 @@
             <a:avLst/>
           </a:prstGeom>
           <a:solidFill>
-            <a:srgbClr val="00D48A"/>
-          </a:solidFill>
-          <a:ln>
-            <a:noFill/>
-          </a:ln>
-        </p:spPr>
-        <p:style>
-          <a:lnRef idx="1">
-            <a:schemeClr val="accent1"/>
-          </a:lnRef>
-          <a:fillRef idx="3">
-            <a:schemeClr val="accent1"/>
-          </a:fillRef>
-          <a:effectRef idx="2">
-            <a:schemeClr val="accent1"/>
-          </a:effectRef>
-          <a:fontRef idx="minor">
-            <a:schemeClr val="lt1"/>
-          </a:fontRef>
-        </p:style>
-        <p:txBody>
-          <a:bodyPr rtlCol="0" anchor="ctr"/>
-          <a:lstStyle/>
-          <a:p>
-            <a:pPr algn="ctr"/>
-            <a:endParaRPr/>
+            <a:srgbClr val="2E7D32"/>
+          </a:solidFill>
+          <a:ln>
+            <a:noFill/>
+          </a:ln>
+        </p:spPr>
+        <p:style>
+          <a:lnRef idx="1">
+            <a:schemeClr val="accent1"/>
+          </a:lnRef>
+          <a:fillRef idx="3">
+            <a:schemeClr val="accent1"/>
+          </a:fillRef>
+          <a:effectRef idx="2">
+            <a:schemeClr val="accent1"/>
+          </a:effectRef>
+          <a:fontRef idx="minor">
+            <a:schemeClr val="lt1"/>
+          </a:fontRef>
+        </p:style>
+        <p:txBody>
+          <a:bodyPr rtlCol="0" anchor="ctr"/>
+          <a:lstStyle/>
+          <a:p>
+            <a:pPr algn="ctr"/>
+            <a:endParaRPr/>
+          </a:p>
+        </p:txBody>
+      </p:sp>
+      <p:sp>
+        <p:nvSpPr>
+          <p:cNvPr id="130" name="Rectangle 129"/>
+          <p:cNvSpPr/>
+          <p:nvPr/>
+        </p:nvSpPr>
+        <p:spPr>
+          <a:xfrm>
+            <a:off x="0" y="0"/>
+            <a:ext cx="9144000" cy="32004"/>
+          </a:xfrm>
+          <a:prstGeom prst="rect">
+            <a:avLst/>
+          </a:prstGeom>
+          <a:solidFill>
+            <a:srgbClr val="D71920"/>
+          </a:solidFill>
+          <a:ln>
+            <a:noFill/>
+          </a:ln>
+        </p:spPr>
+        <p:style>
+          <a:lnRef idx="1">
+            <a:schemeClr val="accent1"/>
+          </a:lnRef>
+          <a:fillRef idx="3">
+            <a:schemeClr val="accent1"/>
+          </a:fillRef>
+          <a:effectRef idx="2">
+            <a:schemeClr val="accent1"/>
+          </a:effectRef>
+          <a:fontRef idx="minor">
+            <a:schemeClr val="lt1"/>
+          </a:fontRef>
+        </p:style>
+        <p:txBody>
+          <a:bodyPr rtlCol="0" anchor="ctr"/>
+          <a:lstStyle/>
+          <a:p>
+            <a:pPr algn="ctr"/>
+          </a:p>
+        </p:txBody>
+      </p:sp>
+      <p:sp>
+        <p:nvSpPr>
+          <p:cNvPr id="131" name="TextBox 130"/>
+          <p:cNvSpPr txBox="1"/>
+          <p:nvPr/>
+        </p:nvSpPr>
+        <p:spPr>
+          <a:xfrm>
+            <a:off x="7699248" y="118872"/>
+            <a:ext cx="1170432" cy="201168"/>
+          </a:xfrm>
+          <a:prstGeom prst="rect">
+            <a:avLst/>
+          </a:prstGeom>
+          <a:noFill/>
+        </p:spPr>
+        <p:txBody>
+          <a:bodyPr wrap="none">
+            <a:spAutoFit/>
+          </a:bodyPr>
+          <a:lstStyle/>
+          <a:p>
+            <a:pPr algn="r"/>
+            <a:r>
+              <a:rPr b="1" sz="1000">
+                <a:solidFill>
+                  <a:srgbClr val="D71920"/>
+                </a:solidFill>
+                <a:latin typeface="Arial"/>
+              </a:rPr>
+              <a:t>HONEYWELL</a:t>
+            </a:r>
           </a:p>
         </p:txBody>
       </p:sp>

</xml_diff>